<commit_message>
Update tech deck for real MLflow + Docker wiring
Sai shipped a working MLflow tracking server on Cloud Run plus a
TF-IDF BookRecommender pipeline (commit 8c161e1). The deck still
described those rows as stubbed / aspirational — update slides 3
and 6 to match reality:

Slide 3 (Stack):
- Docker: two images (app + mlflow-server) deployed to Cloud Run
- MLflow: tracking server on Cloud Run, Cloud SQL + GCS backed,
  registers BookRecommender and promotes to Production
- Cloud Run + Secret Manager: two live services, DB creds in
  Secret Manager, IAM for inter-service auth

Slide 6 (Models):
- Bottom note now describes the separate TF-IDF BookRecommender
  flow: train.py → MLflow on Cloud Run → FastAPI inference.

_update_tech_pptx_mlflow.py: scaffolding for the patch.

Co-Authored-By: Claude Opus 4.7 <noreply@anthropic.com>
</commit_message>
<xml_diff>
--- a/MobyDicks_Tech_v2.pptx
+++ b/MobyDicks_Tech_v2.pptx
@@ -20189,7 +20189,7 @@
                 <a:cs typeface="Calibri"/>
                 <a:sym typeface="Calibri"/>
               </a:rPr>
-              <a:t>Container image targeting Cloud Run; build script in repo root.</a:t>
+              <a:t>Two images: app (FastAPI + baked model) and mlflow-server. Deployed to Cloud Run.</a:t>
             </a:r>
             <a:endParaRPr b="0" i="0" sz="1000" u="none" cap="none" strike="noStrike">
               <a:solidFill>
@@ -20859,7 +20859,7 @@
                 <a:cs typeface="Calibri"/>
                 <a:sym typeface="Calibri"/>
               </a:rPr>
-              <a:t>Run tracking stubbed in CI (MagicMock); planned for Phase 3 reranker.</a:t>
+              <a:t>Cloud Run tracking server (Cloud SQL + GCS artifacts). Registers BookRecommender, promotes to Production.</a:t>
             </a:r>
             <a:endParaRPr b="0" i="0" sz="1000" u="none" cap="none" strike="noStrike">
               <a:solidFill>
@@ -21194,7 +21194,7 @@
                 <a:cs typeface="Calibri"/>
                 <a:sym typeface="Calibri"/>
               </a:rPr>
-              <a:t>Scale-to-zero target; ADC for Vertex AI + BigQuery + Cloud Logging.</a:t>
+              <a:t>Two services live: app + mlflow-server. DB creds via Secret Manager, IAM for inter-service auth.</a:t>
             </a:r>
             <a:endParaRPr b="0" i="0" sz="1000" u="none" cap="none" strike="noStrike">
               <a:solidFill>
@@ -27159,7 +27159,7 @@
                 <a:cs typeface="Calibri"/>
                 <a:sym typeface="Calibri"/>
               </a:rPr>
-              <a:t>the model can only choose from real book_ids in the pool. Phase 2 will add an MLflow-tracked reranker over check-in data.</a:t>
+              <a:t>the model picks from real book_ids only. Separate TF-IDF BookRecommender (train.py) logs to MLflow on Cloud Run and is served via FastAPI on Cloud Run as well.</a:t>
             </a:r>
             <a:endParaRPr b="0" i="0" sz="1000" u="none" cap="none" strike="noStrike">
               <a:solidFill>

</xml_diff>